<commit_message>
Póster SIE 2026: capturas del frontend rediseñado (rama feat/rediseno-visual-dark-mode)
Co-Authored-By: Claude Opus 5.5 <noreply@anthropic.com>
Claude-Session: https://claude.ai/code/session_01V9yfTgsnZSrgfysbnsn61N
</commit_message>
<xml_diff>
--- a/docs/poster/poster_DAI_SIE_2026.pptx
+++ b/docs/poster/poster_DAI_SIE_2026.pptx
@@ -3613,7 +3613,7 @@
                 </a:solidFill>
                 <a:latin typeface="Calibri"/>
               </a:rPr>
-              <a:t>Ingreso con 2FA (TOTP)</a:t>
+              <a:t>Nuevo ingreso con 2FA (TOTP)</a:t>
             </a:r>
           </a:p>
         </p:txBody>
@@ -3662,7 +3662,7 @@
                 <a:ea typeface="Calibri" pitchFamily="34" charset="-122"/>
                 <a:cs typeface="Calibri" pitchFamily="34" charset="-120"/>
               </a:rPr>
-              <a:t xml:space="preserve"> es una aplicación web (Angular 22 + Node/Express + PostgreSQL) para digitalizar, indexar, buscar y custodiar documentos con control de acceso por rol, 2FA y auditoría completa.</a:t>
+              <a:t xml:space="preserve"> es una aplicación web (Angular 22 + Node/Express + PostgreSQL) para digitalizar, indexar, buscar y custodiar documentos con acceso por rol, 2FA, auditoría y tema claro/oscuro.</a:t>
             </a:r>
           </a:p>
         </p:txBody>
@@ -3952,7 +3952,7 @@
                 <a:ea typeface="Calibri" pitchFamily="34" charset="-122"/>
                 <a:cs typeface="Calibri" pitchFamily="34" charset="-120"/>
               </a:rPr>
-              <a:t>pruebas automáticas en verde</a:t>
+              <a:t>pruebas automáticas</a:t>
             </a:r>
           </a:p>
           <a:p>
@@ -3968,7 +3968,7 @@
                 <a:ea typeface="Calibri" pitchFamily="34" charset="-122"/>
                 <a:cs typeface="Calibri" pitchFamily="34" charset="-120"/>
               </a:rPr>
-              <a:t>213 API · 127 Angular</a:t>
+              <a:t>213 de la API · 127 de Angular</a:t>
             </a:r>
           </a:p>
         </p:txBody>
@@ -4521,7 +4521,7 @@
                 <a:ea typeface="Calibri" pitchFamily="34" charset="-122"/>
                 <a:cs typeface="Calibri" pitchFamily="34" charset="-120"/>
               </a:rPr>
-              <a:t>Todas las pruebas pasan</a:t>
+              <a:t>Rediseño visual con tema claro y oscuro</a:t>
             </a:r>
           </a:p>
         </p:txBody>

</xml_diff>